<commit_message>
Add author credit to title slide
Co-Authored-By: Claude Sonnet 5 <noreply@anthropic.com>
</commit_message>
<xml_diff>
--- a/work_and_report/presentations/William_Rodriguez_Offers_NeueFische_Style_2.pptx
+++ b/work_and_report/presentations/William_Rodriguez_Offers_NeueFische_Style_2.pptx
@@ -1959,6 +1959,41 @@
           </a:p>
         </p:txBody>
       </p:sp>
+      <p:sp>
+        <p:nvSpPr>
+          <p:cNvPr id="4" name="TextBox 3"/>
+          <p:cNvSpPr txBox="1"/>
+          <p:nvPr/>
+        </p:nvSpPr>
+        <p:spPr>
+          <a:xfrm>
+            <a:off x="5715400" y="4640580"/>
+            <a:ext cx="3200000" cy="365760"/>
+          </a:xfrm>
+          <a:prstGeom prst="rect">
+            <a:avLst/>
+          </a:prstGeom>
+          <a:noFill/>
+        </p:spPr>
+        <p:txBody>
+          <a:bodyPr wrap="square">
+            <a:spAutoFit/>
+          </a:bodyPr>
+          <a:lstStyle/>
+          <a:p>
+            <a:pPr algn="r"/>
+            <a:r>
+              <a:rPr sz="1100" i="1">
+                <a:solidFill>
+                  <a:srgbClr val="FFFFFF"/>
+                </a:solidFill>
+                <a:latin typeface="Calibri"/>
+              </a:rPr>
+              <a:t>Done by Mohammad Bajbouj &amp; Tim Pfeifer</a:t>
+            </a:r>
+          </a:p>
+        </p:txBody>
+      </p:sp>
     </p:spTree>
   </p:cSld>
   <p:clrMapOvr>

</xml_diff>

<commit_message>
Fix H1 Rural classification to use RUCA codes instead of hardcoded zips
H1 previously defined "Rural" via a 3-zip-code hardcoded list, unlike H3
which uses the authoritative USDA/WWAMI RUCA classification. Switched
H1 to the same RUCA-based location_type for consistency and rigor.

This substantially changes the result: Rural now covers 849 houses
across 49 zip codes (was 3 zips). Re-ran the notebook against the real
database, regenerated both H1 charts and the recommendation doc with
the corrected numbers, and updated the presentation's H1 findings,
criteria, recommendation, and insights slides to match. Also fixed a
bug where the presentation's embedded chart images were stale (pptx
embeds images by value, so overwriting the PNG files on disk alone
doesn't update an already-inserted picture shape).

Co-Authored-By: Claude Sonnet 5 <noreply@anthropic.com>
</commit_message>
<xml_diff>
--- a/work_and_report/presentations/William_Rodriguez_Offers_NeueFische_Style_2.pptx
+++ b/work_and_report/presentations/William_Rodriguez_Offers_NeueFische_Style_2.pptx
@@ -9161,7 +9161,7 @@
                 <a:ea typeface="Calibri" pitchFamily="34" charset="-122"/>
                 <a:cs typeface="Calibri" pitchFamily="34" charset="-120"/>
               </a:rPr>
-              <a:t>• $182.7K - $185K range</a:t>
+              <a:t>• $265K - $271K range</a:t>
             </a:r>
             <a:endParaRPr lang="en-US" sz="1000" dirty="0"/>
           </a:p>
@@ -11293,7 +11293,7 @@
                 <a:ea typeface="Calibri" pitchFamily="34" charset="-122"/>
                 <a:cs typeface="Calibri" pitchFamily="34" charset="-120"/>
               </a:rPr>
-              <a:t>• Rural houses only (3 zip codes)</a:t>
+              <a:t>• Rural = RUCA-classified (849 houses, 49 zips)</a:t>
             </a:r>
             <a:endParaRPr lang="en-US" sz="1100" dirty="0"/>
           </a:p>
@@ -11332,7 +11332,7 @@
                 <a:ea typeface="Calibri" pitchFamily="34" charset="-122"/>
                 <a:cs typeface="Calibri" pitchFamily="34" charset="-120"/>
               </a:rPr>
-              <a:t>• Effect direction varies by size</a:t>
+              <a:t>• Effect direction inconsistent by size</a:t>
             </a:r>
             <a:endParaRPr lang="en-US" sz="1100" dirty="0"/>
           </a:p>
@@ -11371,7 +11371,7 @@
                 <a:ea typeface="Calibri" pitchFamily="34" charset="-122"/>
                 <a:cs typeface="Calibri" pitchFamily="34" charset="-120"/>
               </a:rPr>
-              <a:t>• Medium homes: $8K cheaper (non-reno)</a:t>
+              <a:t>• Medium homes: $1.55K cheaper (non-reno)</a:t>
             </a:r>
             <a:endParaRPr lang="en-US" sz="1100" dirty="0"/>
           </a:p>
@@ -11410,7 +11410,7 @@
                 <a:ea typeface="Calibri" pitchFamily="34" charset="-122"/>
                 <a:cs typeface="Calibri" pitchFamily="34" charset="-120"/>
               </a:rPr>
-              <a:t>• Large homes: $21.75K cheaper (non-reno)</a:t>
+              <a:t>• Large homes: $12.5K pricier (non-reno)</a:t>
             </a:r>
             <a:endParaRPr lang="en-US" sz="1100" dirty="0"/>
           </a:p>
@@ -11449,7 +11449,7 @@
                 <a:ea typeface="Calibri" pitchFamily="34" charset="-122"/>
                 <a:cs typeface="Calibri" pitchFamily="34" charset="-120"/>
               </a:rPr>
-              <a:t>• Small homes: $2.5K pricier (non-reno)</a:t>
+              <a:t>• Small homes: $5.8K pricier (non-reno)</a:t>
             </a:r>
             <a:endParaRPr lang="en-US" sz="1100" dirty="0"/>
           </a:p>
@@ -11673,7 +11673,7 @@
                 <a:ea typeface="Calibri" pitchFamily="34" charset="-122"/>
                 <a:cs typeface="Calibri" pitchFamily="34" charset="-120"/>
               </a:rPr>
-              <a:t>539 houses</a:t>
+              <a:t>279 houses</a:t>
             </a:r>
             <a:endParaRPr lang="en-US" sz="1100" dirty="0"/>
           </a:p>
@@ -11751,7 +11751,7 @@
                 <a:ea typeface="Calibri" pitchFamily="34" charset="-122"/>
                 <a:cs typeface="Calibri" pitchFamily="34" charset="-120"/>
               </a:rPr>
-              <a:t>0.377</a:t>
+              <a:t>0.752</a:t>
             </a:r>
             <a:endParaRPr lang="en-US" sz="1100" dirty="0"/>
           </a:p>
@@ -11907,7 +11907,7 @@
                 <a:ea typeface="Calibri" pitchFamily="34" charset="-122"/>
                 <a:cs typeface="Calibri" pitchFamily="34" charset="-120"/>
               </a:rPr>
-              <a:t>$8,000</a:t>
+              <a:t>$1,550</a:t>
             </a:r>
             <a:endParaRPr lang="en-US" sz="1100" dirty="0"/>
           </a:p>
@@ -11946,7 +11946,7 @@
                 <a:ea typeface="Calibri" pitchFamily="34" charset="-122"/>
                 <a:cs typeface="Calibri" pitchFamily="34" charset="-120"/>
               </a:rPr>
-              <a:t>Rural Zips</a:t>
+              <a:t>Rural Def.</a:t>
             </a:r>
             <a:endParaRPr lang="en-US" sz="1100" dirty="0"/>
           </a:p>
@@ -11985,7 +11985,7 @@
                 <a:ea typeface="Calibri" pitchFamily="34" charset="-122"/>
                 <a:cs typeface="Calibri" pitchFamily="34" charset="-120"/>
               </a:rPr>
-              <a:t>98038/42/23</a:t>
+              <a:t>RUCA codes</a:t>
             </a:r>
             <a:endParaRPr lang="en-US" sz="1100" dirty="0"/>
           </a:p>
@@ -12275,7 +12275,7 @@
                 <a:ea typeface="Calibri" pitchFamily="34" charset="-122"/>
                 <a:cs typeface="Calibri" pitchFamily="34" charset="-120"/>
               </a:rPr>
-              <a:t>✓ Size: Medium (1,677-2,260 sqft)</a:t>
+              <a:t>✓ Size: Medium (1,740-2,550 sqft)</a:t>
             </a:r>
             <a:endParaRPr lang="en-US" sz="1100" dirty="0"/>
           </a:p>
@@ -12772,7 +12772,7 @@
                 <a:ea typeface="Calibri" pitchFamily="34" charset="-122"/>
                 <a:cs typeface="Calibri" pitchFamily="34" charset="-120"/>
               </a:rPr>
-              <a:t>Zipcode</a:t>
+              <a:t>Zipcodes</a:t>
             </a:r>
             <a:endParaRPr lang="en-US" sz="1100" dirty="0"/>
           </a:p>
@@ -12811,7 +12811,7 @@
                 <a:ea typeface="Calibri" pitchFamily="34" charset="-122"/>
                 <a:cs typeface="Calibri" pitchFamily="34" charset="-120"/>
               </a:rPr>
-              <a:t>✓ 98023</a:t>
+              <a:t>✓ 98014 / 98045</a:t>
             </a:r>
             <a:endParaRPr lang="en-US" sz="1100" dirty="0"/>
           </a:p>
@@ -13025,16 +13025,51 @@
           </a:p>
         </p:txBody>
       </p:sp>
+      <p:sp>
+        <p:nvSpPr>
+          <p:cNvPr id="6" name="TextBox 5"/>
+          <p:cNvSpPr txBox="1"/>
+          <p:nvPr/>
+        </p:nvSpPr>
+        <p:spPr>
+          <a:xfrm>
+            <a:off x="457200" y="4980000"/>
+            <a:ext cx="8229600" cy="160000"/>
+          </a:xfrm>
+          <a:prstGeom prst="rect">
+            <a:avLst/>
+          </a:prstGeom>
+          <a:noFill/>
+        </p:spPr>
+        <p:txBody>
+          <a:bodyPr wrap="square">
+            <a:spAutoFit/>
+          </a:bodyPr>
+          <a:lstStyle/>
+          <a:p>
+            <a:pPr algn="ctr"/>
+            <a:r>
+              <a:rPr sz="1000" b="0">
+                <a:solidFill>
+                  <a:srgbClr val="4A4A4A"/>
+                </a:solidFill>
+                <a:latin typeface="Calibri"/>
+              </a:rPr>
+              <a:t>Effect direction is mixed across Small / Medium / Large rural homes</a:t>
+            </a:r>
+          </a:p>
+        </p:txBody>
+      </p:sp>
       <p:pic>
         <p:nvPicPr>
-          <p:cNvPr id="5" name="Picture 4" descr="H1_plot_price_by_renovation_status.png"/>
+          <p:cNvPr id="7" name="Picture 6" descr="H1_plot_price_by_renovation_status.png"/>
           <p:cNvPicPr>
             <a:picLocks noChangeAspect="1"/>
           </p:cNvPicPr>
           <p:nvPr/>
         </p:nvPicPr>
         <p:blipFill>
-          <a:blip r:embed="rId2"/>
+          <a:blip r:embed="rId3"/>
           <a:stretch>
             <a:fillRect/>
           </a:stretch>
@@ -13049,41 +13084,6 @@
           </a:prstGeom>
         </p:spPr>
       </p:pic>
-      <p:sp>
-        <p:nvSpPr>
-          <p:cNvPr id="6" name="TextBox 5"/>
-          <p:cNvSpPr txBox="1"/>
-          <p:nvPr/>
-        </p:nvSpPr>
-        <p:spPr>
-          <a:xfrm>
-            <a:off x="457200" y="4980000"/>
-            <a:ext cx="8229600" cy="160000"/>
-          </a:xfrm>
-          <a:prstGeom prst="rect">
-            <a:avLst/>
-          </a:prstGeom>
-          <a:noFill/>
-        </p:spPr>
-        <p:txBody>
-          <a:bodyPr wrap="square">
-            <a:spAutoFit/>
-          </a:bodyPr>
-          <a:lstStyle/>
-          <a:p>
-            <a:pPr algn="ctr"/>
-            <a:r>
-              <a:rPr sz="1000" b="0">
-                <a:solidFill>
-                  <a:srgbClr val="4A4A4A"/>
-                </a:solidFill>
-                <a:latin typeface="Calibri"/>
-              </a:rPr>
-              <a:t>Effect direction is mixed across Small / Medium / Large rural homes</a:t>
-            </a:r>
-          </a:p>
-        </p:txBody>
-      </p:sp>
     </p:spTree>
   </p:cSld>
   <p:clrMapOvr>
@@ -13214,16 +13214,51 @@
           </a:p>
         </p:txBody>
       </p:sp>
+      <p:sp>
+        <p:nvSpPr>
+          <p:cNvPr id="6" name="TextBox 5"/>
+          <p:cNvSpPr txBox="1"/>
+          <p:nvPr/>
+        </p:nvSpPr>
+        <p:spPr>
+          <a:xfrm>
+            <a:off x="457200" y="4980000"/>
+            <a:ext cx="8229600" cy="160000"/>
+          </a:xfrm>
+          <a:prstGeom prst="rect">
+            <a:avLst/>
+          </a:prstGeom>
+          <a:noFill/>
+        </p:spPr>
+        <p:txBody>
+          <a:bodyPr wrap="square">
+            <a:spAutoFit/>
+          </a:bodyPr>
+          <a:lstStyle/>
+          <a:p>
+            <a:pPr algn="ctr"/>
+            <a:r>
+              <a:rPr sz="1000" b="0">
+                <a:solidFill>
+                  <a:srgbClr val="4A4A4A"/>
+                </a:solidFill>
+                <a:latin typeface="Calibri"/>
+              </a:rPr>
+              <a:t>Focus view: the size band actually used for William's two candidates</a:t>
+            </a:r>
+          </a:p>
+        </p:txBody>
+      </p:sp>
       <p:pic>
         <p:nvPicPr>
-          <p:cNvPr id="5" name="Picture 4" descr="H1_plot_price_by_renovation_status_medium.png"/>
+          <p:cNvPr id="7" name="Picture 6" descr="H1_plot_price_by_renovation_status_medium.png"/>
           <p:cNvPicPr>
             <a:picLocks noChangeAspect="1"/>
           </p:cNvPicPr>
           <p:nvPr/>
         </p:nvPicPr>
         <p:blipFill>
-          <a:blip r:embed="rId2"/>
+          <a:blip r:embed="rId3"/>
           <a:stretch>
             <a:fillRect/>
           </a:stretch>
@@ -13238,41 +13273,6 @@
           </a:prstGeom>
         </p:spPr>
       </p:pic>
-      <p:sp>
-        <p:nvSpPr>
-          <p:cNvPr id="6" name="TextBox 5"/>
-          <p:cNvSpPr txBox="1"/>
-          <p:nvPr/>
-        </p:nvSpPr>
-        <p:spPr>
-          <a:xfrm>
-            <a:off x="457200" y="4980000"/>
-            <a:ext cx="8229600" cy="160000"/>
-          </a:xfrm>
-          <a:prstGeom prst="rect">
-            <a:avLst/>
-          </a:prstGeom>
-          <a:noFill/>
-        </p:spPr>
-        <p:txBody>
-          <a:bodyPr wrap="square">
-            <a:spAutoFit/>
-          </a:bodyPr>
-          <a:lstStyle/>
-          <a:p>
-            <a:pPr algn="ctr"/>
-            <a:r>
-              <a:rPr sz="1000" b="0">
-                <a:solidFill>
-                  <a:srgbClr val="4A4A4A"/>
-                </a:solidFill>
-                <a:latin typeface="Calibri"/>
-              </a:rPr>
-              <a:t>Focus view: the size band actually used for William's two candidates</a:t>
-            </a:r>
-          </a:p>
-        </p:txBody>
-      </p:sp>
     </p:spTree>
   </p:cSld>
   <p:clrMapOvr>
@@ -13477,7 +13477,7 @@
                 </a:solidFill>
                 <a:latin typeface="Calibri"/>
               </a:rPr>
-              <a:t>House #1 - Zip 98023</a:t>
+              <a:t>House #1 - Zip 98014</a:t>
             </a:r>
           </a:p>
         </p:txBody>
@@ -13547,7 +13547,7 @@
                 </a:solidFill>
                 <a:latin typeface="Calibri"/>
               </a:rPr>
-              <a:t>$182,700</a:t>
+              <a:t>$265,000</a:t>
             </a:r>
           </a:p>
         </p:txBody>
@@ -13617,7 +13617,7 @@
                 </a:solidFill>
                 <a:latin typeface="Calibri"/>
               </a:rPr>
-              <a:t>1,740 sqft</a:t>
+              <a:t>1,850 sqft</a:t>
             </a:r>
           </a:p>
         </p:txBody>
@@ -13687,7 +13687,7 @@
                 </a:solidFill>
                 <a:latin typeface="Calibri"/>
               </a:rPr>
-              <a:t>3 / 2.25</a:t>
+              <a:t>3 / 2.0</a:t>
             </a:r>
           </a:p>
         </p:txBody>
@@ -13757,7 +13757,7 @@
                 </a:solidFill>
                 <a:latin typeface="Calibri"/>
               </a:rPr>
-              <a:t>1978</a:t>
+              <a:t>1992</a:t>
             </a:r>
           </a:p>
         </p:txBody>
@@ -13827,7 +13827,7 @@
                 </a:solidFill>
                 <a:latin typeface="Calibri"/>
               </a:rPr>
-              <a:t>6,650 sqft</a:t>
+              <a:t>16,535 sqft</a:t>
             </a:r>
           </a:p>
         </p:txBody>
@@ -13897,7 +13897,7 @@
                 </a:solidFill>
                 <a:latin typeface="Calibri"/>
               </a:rPr>
-              <a:t>✓ Rural, quiet, no close neighbors</a:t>
+              <a:t>✓ Genuinely rural (RUCA-classified)</a:t>
             </a:r>
           </a:p>
         </p:txBody>
@@ -14046,7 +14046,7 @@
                 </a:solidFill>
                 <a:latin typeface="Calibri"/>
               </a:rPr>
-              <a:t>House #2 - Zip 98023</a:t>
+              <a:t>House #2 - Zip 98045</a:t>
             </a:r>
           </a:p>
         </p:txBody>
@@ -14116,7 +14116,7 @@
                 </a:solidFill>
                 <a:latin typeface="Calibri"/>
               </a:rPr>
-              <a:t>$185,000</a:t>
+              <a:t>$271,000</a:t>
             </a:r>
           </a:p>
         </p:txBody>
@@ -14186,7 +14186,7 @@
                 </a:solidFill>
                 <a:latin typeface="Calibri"/>
               </a:rPr>
-              <a:t>1,990 sqft</a:t>
+              <a:t>1,800 sqft</a:t>
             </a:r>
           </a:p>
         </p:txBody>
@@ -14256,7 +14256,7 @@
                 </a:solidFill>
                 <a:latin typeface="Calibri"/>
               </a:rPr>
-              <a:t>5 / 1.75</a:t>
+              <a:t>4 / 1.5</a:t>
             </a:r>
           </a:p>
         </p:txBody>
@@ -14326,7 +14326,7 @@
                 </a:solidFill>
                 <a:latin typeface="Calibri"/>
               </a:rPr>
-              <a:t>1955</a:t>
+              <a:t>1977</a:t>
             </a:r>
           </a:p>
         </p:txBody>
@@ -14396,7 +14396,7 @@
                 </a:solidFill>
                 <a:latin typeface="Calibri"/>
               </a:rPr>
-              <a:t>27,810 sqft</a:t>
+              <a:t>9,576 sqft</a:t>
             </a:r>
           </a:p>
         </p:txBody>
@@ -14466,7 +14466,7 @@
                 </a:solidFill>
                 <a:latin typeface="Calibri"/>
               </a:rPr>
-              <a:t>✓ Much larger lot for the dog</a:t>
+              <a:t>✓ More bedrooms, similar price</a:t>
             </a:r>
           </a:p>
         </p:txBody>
@@ -14501,7 +14501,7 @@
                 </a:solidFill>
                 <a:latin typeface="Calibri"/>
               </a:rPr>
-              <a:t>✓ More bedrooms, similar price</a:t>
+              <a:t>✓ Genuinely rural (RUCA-classified)</a:t>
             </a:r>
           </a:p>
         </p:txBody>

</xml_diff>

<commit_message>
create folder for own figures
</commit_message>
<xml_diff>
--- a/work_and_report/presentations/William_Rodriguez_Offers_NeueFische_Style_2.pptx
+++ b/work_and_report/presentations/William_Rodriguez_Offers_NeueFische_Style_2.pptx
@@ -9161,7 +9161,7 @@
                 <a:ea typeface="Calibri" pitchFamily="34" charset="-122"/>
                 <a:cs typeface="Calibri" pitchFamily="34" charset="-120"/>
               </a:rPr>
-              <a:t>• $265K - $271K range</a:t>
+              <a:t>• $182.7K - $185K range</a:t>
             </a:r>
             <a:endParaRPr lang="en-US" sz="1000" dirty="0"/>
           </a:p>
@@ -11293,7 +11293,7 @@
                 <a:ea typeface="Calibri" pitchFamily="34" charset="-122"/>
                 <a:cs typeface="Calibri" pitchFamily="34" charset="-120"/>
               </a:rPr>
-              <a:t>• Rural = RUCA-classified (849 houses)</a:t>
+              <a:t>• Rural houses only (3 zip codes)</a:t>
             </a:r>
             <a:endParaRPr lang="en-US" sz="1100" dirty="0"/>
           </a:p>
@@ -11332,7 +11332,7 @@
                 <a:ea typeface="Calibri" pitchFamily="34" charset="-122"/>
                 <a:cs typeface="Calibri" pitchFamily="34" charset="-120"/>
               </a:rPr>
-              <a:t>• Effect direction inconsistent by size</a:t>
+              <a:t>• Effect direction varies by size</a:t>
             </a:r>
             <a:endParaRPr lang="en-US" sz="1100" dirty="0"/>
           </a:p>
@@ -11371,7 +11371,7 @@
                 <a:ea typeface="Calibri" pitchFamily="34" charset="-122"/>
                 <a:cs typeface="Calibri" pitchFamily="34" charset="-120"/>
               </a:rPr>
-              <a:t>• Medium homes: $1.55K cheaper (non-reno)</a:t>
+              <a:t>• Medium homes: $8K cheaper (non-reno)</a:t>
             </a:r>
             <a:endParaRPr lang="en-US" sz="1100" dirty="0"/>
           </a:p>
@@ -11410,7 +11410,7 @@
                 <a:ea typeface="Calibri" pitchFamily="34" charset="-122"/>
                 <a:cs typeface="Calibri" pitchFamily="34" charset="-120"/>
               </a:rPr>
-              <a:t>• Large homes: $12.5K pricier (non-reno)</a:t>
+              <a:t>• Large homes: $21.75K cheaper (non-reno)</a:t>
             </a:r>
             <a:endParaRPr lang="en-US" sz="1100" dirty="0"/>
           </a:p>
@@ -11449,7 +11449,7 @@
                 <a:ea typeface="Calibri" pitchFamily="34" charset="-122"/>
                 <a:cs typeface="Calibri" pitchFamily="34" charset="-120"/>
               </a:rPr>
-              <a:t>• Small homes: $5.8K pricier (non-reno)</a:t>
+              <a:t>• Small homes: $2.5K pricier (non-reno)</a:t>
             </a:r>
             <a:endParaRPr lang="en-US" sz="1100" dirty="0"/>
           </a:p>
@@ -11673,7 +11673,7 @@
                 <a:ea typeface="Calibri" pitchFamily="34" charset="-122"/>
                 <a:cs typeface="Calibri" pitchFamily="34" charset="-120"/>
               </a:rPr>
-              <a:t>279 houses</a:t>
+              <a:t>539 houses</a:t>
             </a:r>
             <a:endParaRPr lang="en-US" sz="1100" dirty="0"/>
           </a:p>
@@ -11751,7 +11751,7 @@
                 <a:ea typeface="Calibri" pitchFamily="34" charset="-122"/>
                 <a:cs typeface="Calibri" pitchFamily="34" charset="-120"/>
               </a:rPr>
-              <a:t>0.752</a:t>
+              <a:t>0.377</a:t>
             </a:r>
             <a:endParaRPr lang="en-US" sz="1100" dirty="0"/>
           </a:p>
@@ -11907,7 +11907,7 @@
                 <a:ea typeface="Calibri" pitchFamily="34" charset="-122"/>
                 <a:cs typeface="Calibri" pitchFamily="34" charset="-120"/>
               </a:rPr>
-              <a:t>$1,550</a:t>
+              <a:t>$8,000</a:t>
             </a:r>
             <a:endParaRPr lang="en-US" sz="1100" dirty="0"/>
           </a:p>
@@ -11946,7 +11946,7 @@
                 <a:ea typeface="Calibri" pitchFamily="34" charset="-122"/>
                 <a:cs typeface="Calibri" pitchFamily="34" charset="-120"/>
               </a:rPr>
-              <a:t>Rural Def.</a:t>
+              <a:t>Rural Zips</a:t>
             </a:r>
             <a:endParaRPr lang="en-US" sz="1100" dirty="0"/>
           </a:p>
@@ -11985,7 +11985,7 @@
                 <a:ea typeface="Calibri" pitchFamily="34" charset="-122"/>
                 <a:cs typeface="Calibri" pitchFamily="34" charset="-120"/>
               </a:rPr>
-              <a:t>RUCA codes</a:t>
+              <a:t>98038/42/23</a:t>
             </a:r>
             <a:endParaRPr lang="en-US" sz="1100" dirty="0"/>
           </a:p>
@@ -12275,7 +12275,7 @@
                 <a:ea typeface="Calibri" pitchFamily="34" charset="-122"/>
                 <a:cs typeface="Calibri" pitchFamily="34" charset="-120"/>
               </a:rPr>
-              <a:t>✓ Size: Medium (1,740-2,550 sqft)</a:t>
+              <a:t>✓ Size: Medium (1,677-2,260 sqft)</a:t>
             </a:r>
             <a:endParaRPr lang="en-US" sz="1100" dirty="0"/>
           </a:p>
@@ -12772,7 +12772,7 @@
                 <a:ea typeface="Calibri" pitchFamily="34" charset="-122"/>
                 <a:cs typeface="Calibri" pitchFamily="34" charset="-120"/>
               </a:rPr>
-              <a:t>Zipcodes</a:t>
+              <a:t>Zipcode</a:t>
             </a:r>
             <a:endParaRPr lang="en-US" sz="1100" dirty="0"/>
           </a:p>
@@ -12811,7 +12811,7 @@
                 <a:ea typeface="Calibri" pitchFamily="34" charset="-122"/>
                 <a:cs typeface="Calibri" pitchFamily="34" charset="-120"/>
               </a:rPr>
-              <a:t>✓ 98014 / 98045</a:t>
+              <a:t>✓ 98023</a:t>
             </a:r>
             <a:endParaRPr lang="en-US" sz="1100" dirty="0"/>
           </a:p>
@@ -13062,14 +13062,14 @@
       </p:sp>
       <p:pic>
         <p:nvPicPr>
-          <p:cNvPr id="7" name="Picture 6" descr="H1_plot_price_by_renovation_status.png"/>
+          <p:cNvPr id="7" name="Picture 6" descr="image.png"/>
           <p:cNvPicPr>
             <a:picLocks noChangeAspect="1"/>
           </p:cNvPicPr>
           <p:nvPr/>
         </p:nvPicPr>
         <p:blipFill>
-          <a:blip r:embed="rId3"/>
+          <a:blip r:embed="rId2"/>
           <a:stretch>
             <a:fillRect/>
           </a:stretch>
@@ -13251,14 +13251,14 @@
       </p:sp>
       <p:pic>
         <p:nvPicPr>
-          <p:cNvPr id="7" name="Picture 6" descr="H1_plot_price_by_renovation_status_medium.png"/>
+          <p:cNvPr id="7" name="Picture 6" descr="image.png"/>
           <p:cNvPicPr>
             <a:picLocks noChangeAspect="1"/>
           </p:cNvPicPr>
           <p:nvPr/>
         </p:nvPicPr>
         <p:blipFill>
-          <a:blip r:embed="rId3"/>
+          <a:blip r:embed="rId2"/>
           <a:stretch>
             <a:fillRect/>
           </a:stretch>
@@ -13477,7 +13477,7 @@
                 </a:solidFill>
                 <a:latin typeface="Calibri"/>
               </a:rPr>
-              <a:t>House #1 - Zip 98014</a:t>
+              <a:t>House #1 - Zip 98023</a:t>
             </a:r>
           </a:p>
         </p:txBody>
@@ -13547,7 +13547,7 @@
                 </a:solidFill>
                 <a:latin typeface="Calibri"/>
               </a:rPr>
-              <a:t>$265,000</a:t>
+              <a:t>$182,700</a:t>
             </a:r>
           </a:p>
         </p:txBody>
@@ -13617,7 +13617,7 @@
                 </a:solidFill>
                 <a:latin typeface="Calibri"/>
               </a:rPr>
-              <a:t>1,850 sqft</a:t>
+              <a:t>1,740 sqft</a:t>
             </a:r>
           </a:p>
         </p:txBody>
@@ -13687,7 +13687,7 @@
                 </a:solidFill>
                 <a:latin typeface="Calibri"/>
               </a:rPr>
-              <a:t>3 / 2.0</a:t>
+              <a:t>3 / 2.25</a:t>
             </a:r>
           </a:p>
         </p:txBody>
@@ -13757,7 +13757,7 @@
                 </a:solidFill>
                 <a:latin typeface="Calibri"/>
               </a:rPr>
-              <a:t>1992</a:t>
+              <a:t>1978</a:t>
             </a:r>
           </a:p>
         </p:txBody>
@@ -13827,7 +13827,7 @@
                 </a:solidFill>
                 <a:latin typeface="Calibri"/>
               </a:rPr>
-              <a:t>16,535 sqft</a:t>
+              <a:t>6,650 sqft</a:t>
             </a:r>
           </a:p>
         </p:txBody>
@@ -13897,7 +13897,7 @@
                 </a:solidFill>
                 <a:latin typeface="Calibri"/>
               </a:rPr>
-              <a:t>✓ Genuinely rural (RUCA-classified)</a:t>
+              <a:t>✓ Rural, quiet, no close neighbors</a:t>
             </a:r>
           </a:p>
         </p:txBody>
@@ -14046,7 +14046,7 @@
                 </a:solidFill>
                 <a:latin typeface="Calibri"/>
               </a:rPr>
-              <a:t>House #2 - Zip 98045</a:t>
+              <a:t>House #2 - Zip 98023</a:t>
             </a:r>
           </a:p>
         </p:txBody>
@@ -14116,7 +14116,7 @@
                 </a:solidFill>
                 <a:latin typeface="Calibri"/>
               </a:rPr>
-              <a:t>$271,000</a:t>
+              <a:t>$185,000</a:t>
             </a:r>
           </a:p>
         </p:txBody>
@@ -14186,7 +14186,7 @@
                 </a:solidFill>
                 <a:latin typeface="Calibri"/>
               </a:rPr>
-              <a:t>1,800 sqft</a:t>
+              <a:t>1,990 sqft</a:t>
             </a:r>
           </a:p>
         </p:txBody>
@@ -14256,7 +14256,7 @@
                 </a:solidFill>
                 <a:latin typeface="Calibri"/>
               </a:rPr>
-              <a:t>4 / 1.5</a:t>
+              <a:t>5 / 1.75</a:t>
             </a:r>
           </a:p>
         </p:txBody>
@@ -14326,7 +14326,7 @@
                 </a:solidFill>
                 <a:latin typeface="Calibri"/>
               </a:rPr>
-              <a:t>1977</a:t>
+              <a:t>1955</a:t>
             </a:r>
           </a:p>
         </p:txBody>
@@ -14396,7 +14396,7 @@
                 </a:solidFill>
                 <a:latin typeface="Calibri"/>
               </a:rPr>
-              <a:t>9,576 sqft</a:t>
+              <a:t>27,810 sqft</a:t>
             </a:r>
           </a:p>
         </p:txBody>
@@ -14466,7 +14466,7 @@
                 </a:solidFill>
                 <a:latin typeface="Calibri"/>
               </a:rPr>
-              <a:t>✓ More bedrooms, similar price</a:t>
+              <a:t>✓ Much larger lot for the dog</a:t>
             </a:r>
           </a:p>
         </p:txBody>
@@ -14501,7 +14501,7 @@
                 </a:solidFill>
                 <a:latin typeface="Calibri"/>
               </a:rPr>
-              <a:t>✓ Genuinely rural (RUCA-classified)</a:t>
+              <a:t>✓ More bedrooms, similar price</a:t>
             </a:r>
           </a:p>
         </p:txBody>

</xml_diff>

<commit_message>
Add H1 methodology note: zip code alone can't identify rural vs urban
Adds a short evidence slide (and matching section in
H1_House_Recommendations.md) documenting the attempt to derive a
rural/urban split from zip-code-level housing patterns (lot size,
distance from downtown, sales count) instead of an external source.
The best single-feature rule still missed 3 of 5 true RUCA-rural zip
codes, and high accuracy scores were misleading given the class
imbalance (guessing "Urban" always scores >90%). Conclusion: zip code
alone is not a sufficient method for this classification, so H1's
current 3-zip-code definition is a simplification, not a validated
one.

Co-Authored-By: Claude Sonnet 5 <noreply@anthropic.com>
</commit_message>
<xml_diff>
--- a/work_and_report/presentations/William_Rodriguez_Offers_NeueFische_Style_2.pptx
+++ b/work_and_report/presentations/William_Rodriguez_Offers_NeueFische_Style_2.pptx
@@ -14,6 +14,7 @@
     <p:sldId id="269" r:id="rId20"/>
     <p:sldId id="270" r:id="rId21"/>
     <p:sldId id="268" r:id="rId19"/>
+    <p:sldId id="278" r:id="rId29"/>
     <p:sldId id="262" r:id="rId8"/>
     <p:sldId id="263" r:id="rId9"/>
     <p:sldId id="264" r:id="rId10"/>
@@ -9637,6 +9638,287 @@
 </p:sld>
 </file>
 
+<file path=ppt/slides/slide23.xml><?xml version="1.0" encoding="utf-8"?>
+<p:sld xmlns:a="http://schemas.openxmlformats.org/drawingml/2006/main" xmlns:p="http://schemas.openxmlformats.org/presentationml/2006/main" xmlns:r="http://schemas.openxmlformats.org/officeDocument/2006/relationships">
+  <p:cSld>
+    <p:spTree>
+      <p:nvGrpSpPr>
+        <p:cNvPr id="1" name=""/>
+        <p:cNvGrpSpPr/>
+        <p:nvPr/>
+      </p:nvGrpSpPr>
+      <p:grpSpPr/>
+      <p:sp>
+        <p:nvSpPr>
+          <p:cNvPr id="2" name="TextBox 1"/>
+          <p:cNvSpPr txBox="1"/>
+          <p:nvPr/>
+        </p:nvSpPr>
+        <p:spPr>
+          <a:xfrm>
+            <a:off x="457200" y="274320"/>
+            <a:ext cx="8229600" cy="457200"/>
+          </a:xfrm>
+          <a:prstGeom prst="rect">
+            <a:avLst/>
+          </a:prstGeom>
+          <a:noFill/>
+        </p:spPr>
+        <p:txBody>
+          <a:bodyPr wrap="none">
+            <a:spAutoFit/>
+          </a:bodyPr>
+          <a:lstStyle/>
+          <a:p>
+            <a:r>
+              <a:rPr sz="1400" b="1">
+                <a:solidFill>
+                  <a:srgbClr val="FF6B54"/>
+                </a:solidFill>
+                <a:latin typeface="Calibri"/>
+              </a:rPr>
+              <a:t>H1 Methodology Note</a:t>
+            </a:r>
+          </a:p>
+        </p:txBody>
+      </p:sp>
+      <p:sp>
+        <p:nvSpPr>
+          <p:cNvPr id="3" name="TextBox 2"/>
+          <p:cNvSpPr txBox="1"/>
+          <p:nvPr/>
+        </p:nvSpPr>
+        <p:spPr>
+          <a:xfrm>
+            <a:off x="457200" y="731520"/>
+            <a:ext cx="8229600" cy="365760"/>
+          </a:xfrm>
+          <a:prstGeom prst="rect">
+            <a:avLst/>
+          </a:prstGeom>
+          <a:noFill/>
+        </p:spPr>
+        <p:txBody>
+          <a:bodyPr wrap="none">
+            <a:spAutoFit/>
+          </a:bodyPr>
+          <a:lstStyle/>
+          <a:p>
+            <a:r>
+              <a:rPr sz="2800" b="1">
+                <a:solidFill>
+                  <a:srgbClr val="1E3A5F"/>
+                </a:solidFill>
+                <a:latin typeface="Calibri"/>
+              </a:rPr>
+              <a:t>Zip Code Alone Can't Identify Rural vs Urban</a:t>
+            </a:r>
+          </a:p>
+        </p:txBody>
+      </p:sp>
+      <p:sp>
+        <p:nvSpPr>
+          <p:cNvPr id="4" name="Rectangle 3"/>
+          <p:cNvSpPr/>
+          <p:nvPr/>
+        </p:nvSpPr>
+        <p:spPr>
+          <a:xfrm>
+            <a:off x="0" y="1188720"/>
+            <a:ext cx="9144000" cy="137160"/>
+          </a:xfrm>
+          <a:prstGeom prst="rect">
+            <a:avLst/>
+          </a:prstGeom>
+          <a:solidFill>
+            <a:srgbClr val="FF6B54"/>
+          </a:solidFill>
+          <a:ln>
+            <a:noFill/>
+          </a:ln>
+          <a:effectLst/>
+        </p:spPr>
+        <p:style>
+          <a:lnRef idx="1">
+            <a:schemeClr val="accent1"/>
+          </a:lnRef>
+          <a:fillRef idx="3">
+            <a:schemeClr val="accent1"/>
+          </a:fillRef>
+          <a:effectRef idx="2">
+            <a:schemeClr val="accent1"/>
+          </a:effectRef>
+          <a:fontRef idx="minor">
+            <a:schemeClr val="lt1"/>
+          </a:fontRef>
+        </p:style>
+        <p:txBody>
+          <a:bodyPr rtlCol="0" anchor="ctr"/>
+          <a:lstStyle/>
+          <a:p>
+            <a:pPr algn="ctr"/>
+          </a:p>
+        </p:txBody>
+      </p:sp>
+      <p:sp>
+        <p:nvSpPr>
+          <p:cNvPr id="5" name="TextBox 4"/>
+          <p:cNvSpPr txBox="1"/>
+          <p:nvPr/>
+        </p:nvSpPr>
+        <p:spPr>
+          <a:xfrm>
+            <a:off x="457200" y="1500000"/>
+            <a:ext cx="8229600" cy="3300000"/>
+          </a:xfrm>
+          <a:prstGeom prst="rect">
+            <a:avLst/>
+          </a:prstGeom>
+          <a:noFill/>
+        </p:spPr>
+        <p:txBody>
+          <a:bodyPr wrap="square">
+            <a:spAutoFit/>
+          </a:bodyPr>
+          <a:lstStyle/>
+          <a:p>
+            <a:pPr>
+              <a:spcAft>
+                <a:spcPts val="1400"/>
+              </a:spcAft>
+            </a:pPr>
+            <a:r>
+              <a:rPr sz="1400">
+                <a:solidFill>
+                  <a:srgbClr val="4A4A4A"/>
+                </a:solidFill>
+                <a:latin typeface="Calibri"/>
+              </a:rPr>
+              <a:t>• We tried to identify Rural zip codes using only patterns already in the housing data: lot size, distance from downtown, and sales per zip.</a:t>
+            </a:r>
+          </a:p>
+          <a:p>
+            <a:pPr>
+              <a:spcAft>
+                <a:spcPts val="1400"/>
+              </a:spcAft>
+            </a:pPr>
+            <a:r>
+              <a:rPr sz="1400">
+                <a:solidFill>
+                  <a:srgbClr val="4A4A4A"/>
+                </a:solidFill>
+                <a:latin typeface="Calibri"/>
+              </a:rPr>
+              <a:t>• The idea: large lots, long distances, and few sales should signal “Rural.”</a:t>
+            </a:r>
+          </a:p>
+          <a:p>
+            <a:pPr>
+              <a:spcAft>
+                <a:spcPts val="1400"/>
+              </a:spcAft>
+            </a:pPr>
+            <a:r>
+              <a:rPr sz="1400">
+                <a:solidFill>
+                  <a:srgbClr val="4A4A4A"/>
+                </a:solidFill>
+                <a:latin typeface="Calibri"/>
+              </a:rPr>
+              <a:t>• We tested the best possible threshold for each signal against the official RUCA rural/urban classification.</a:t>
+            </a:r>
+          </a:p>
+          <a:p>
+            <a:pPr>
+              <a:spcAft>
+                <a:spcPts val="1400"/>
+              </a:spcAft>
+            </a:pPr>
+            <a:r>
+              <a:rPr sz="1400">
+                <a:solidFill>
+                  <a:srgbClr val="4A4A4A"/>
+                </a:solidFill>
+                <a:latin typeface="Calibri"/>
+              </a:rPr>
+              <a:t>• Even the best rule missed 3 of the 5 real Rural zip codes.</a:t>
+            </a:r>
+          </a:p>
+          <a:p>
+            <a:pPr>
+              <a:spcAft>
+                <a:spcPts val="1400"/>
+              </a:spcAft>
+            </a:pPr>
+            <a:r>
+              <a:rPr sz="1400">
+                <a:solidFill>
+                  <a:srgbClr val="4A4A4A"/>
+                </a:solidFill>
+                <a:latin typeface="Calibri"/>
+              </a:rPr>
+              <a:t>• Some zip codes with huge average lots (over 38,000 sqft) are actually Urban.</a:t>
+            </a:r>
+          </a:p>
+          <a:p>
+            <a:pPr>
+              <a:spcAft>
+                <a:spcPts val="1400"/>
+              </a:spcAft>
+            </a:pPr>
+            <a:r>
+              <a:rPr sz="1400">
+                <a:solidFill>
+                  <a:srgbClr val="4A4A4A"/>
+                </a:solidFill>
+                <a:latin typeface="Calibri"/>
+              </a:rPr>
+              <a:t>• Some zip codes with small average lots are actually Rural.</a:t>
+            </a:r>
+          </a:p>
+          <a:p>
+            <a:pPr>
+              <a:spcAft>
+                <a:spcPts val="1400"/>
+              </a:spcAft>
+            </a:pPr>
+            <a:r>
+              <a:rPr sz="1400">
+                <a:solidFill>
+                  <a:srgbClr val="4A4A4A"/>
+                </a:solidFill>
+                <a:latin typeface="Calibri"/>
+              </a:rPr>
+              <a:t>• High accuracy scores were misleading — guessing “Urban” every time already scores over 90%.</a:t>
+            </a:r>
+          </a:p>
+          <a:p>
+            <a:pPr>
+              <a:spcAft>
+                <a:spcPts val="1400"/>
+              </a:spcAft>
+            </a:pPr>
+            <a:r>
+              <a:rPr sz="1400">
+                <a:solidFill>
+                  <a:srgbClr val="4A4A4A"/>
+                </a:solidFill>
+                <a:latin typeface="Calibri"/>
+              </a:rPr>
+              <a:t>• Conclusion: zip code alone cannot reliably separate Rural from Urban in this dataset.</a:t>
+            </a:r>
+          </a:p>
+        </p:txBody>
+      </p:sp>
+    </p:spTree>
+  </p:cSld>
+  <p:clrMapOvr>
+    <a:masterClrMapping/>
+  </p:clrMapOvr>
+</p:sld>
+</file>
+
 <file path=ppt/slides/slide3.xml><?xml version="1.0" encoding="utf-8"?>
 <p:sld xmlns:a="http://schemas.openxmlformats.org/drawingml/2006/main" xmlns:r="http://schemas.openxmlformats.org/officeDocument/2006/relationships" xmlns:p="http://schemas.openxmlformats.org/presentationml/2006/main">
   <p:cSld name="Slide 3">

</xml_diff>